<commit_message>
feat: add ProfileSwitcher component for user profile management
feat: implement CreatorChatModal for creator collaboration chat interface

feat: create calendar route for managing user events with S3 storage integration
</commit_message>
<xml_diff>
--- a/docs/performance-report.pptx
+++ b/docs/performance-report.pptx
@@ -4131,7 +4131,7 @@
         <p:spPr>
           <a:xfrm>
             <a:off x="365760" y="2670048"/>
-            <a:ext cx="5029200" cy="3108960"/>
+            <a:ext cx="5029200" cy="3941064"/>
           </a:xfrm>
           <a:prstGeom prst="rect">
             <a:avLst/>
@@ -5114,7 +5114,7 @@
         <p:spPr>
           <a:xfrm>
             <a:off x="5577840" y="2670048"/>
-            <a:ext cx="4297680" cy="3108960"/>
+            <a:ext cx="4297680" cy="3941064"/>
           </a:xfrm>
           <a:prstGeom prst="rect">
             <a:avLst/>
@@ -6191,7 +6191,7 @@
         <p:spPr>
           <a:xfrm>
             <a:off x="10058400" y="2670048"/>
-            <a:ext cx="4206240" cy="1444752"/>
+            <a:ext cx="4206240" cy="2386584"/>
           </a:xfrm>
           <a:prstGeom prst="rect">
             <a:avLst/>
@@ -6528,7 +6528,7 @@
                   <a:srgbClr val="C8D7EB"/>
                 </a:solidFill>
               </a:rPr>
-              <a:t>JWT · bcrypt · Helmet · Rate Limiting</a:t>
+              <a:t>JWT · bcrypt · Helmet · CORS · Express Rate Limit</a:t>
             </a:r>
           </a:p>
         </p:txBody>
@@ -6596,7 +6596,7 @@
                   <a:srgbClr val="C8D7EB"/>
                 </a:solidFill>
               </a:rPr>
-              <a:t>Jest 468+ tests · K6 Load · fast-check</a:t>
+              <a:t>Jest · K6 (load) · Supertest · fast-check</a:t>
             </a:r>
           </a:p>
         </p:txBody>
@@ -6609,8 +6609,8 @@
         </p:nvSpPr>
         <p:spPr>
           <a:xfrm>
-            <a:off x="10058400" y="4224528"/>
-            <a:ext cx="4206240" cy="1554480"/>
+            <a:off x="10058400" y="5166360"/>
+            <a:ext cx="4206240" cy="1728216"/>
           </a:xfrm>
           <a:prstGeom prst="rect">
             <a:avLst/>
@@ -6654,7 +6654,7 @@
         </p:nvSpPr>
         <p:spPr>
           <a:xfrm>
-            <a:off x="10241280" y="4297680"/>
+            <a:off x="10241280" y="5239512"/>
             <a:ext cx="3840480" cy="329184"/>
           </a:xfrm>
           <a:prstGeom prst="rect">
@@ -6688,7 +6688,7 @@
         </p:nvSpPr>
         <p:spPr>
           <a:xfrm>
-            <a:off x="10241280" y="4681728"/>
+            <a:off x="10241280" y="5623560"/>
             <a:ext cx="3931920" cy="274320"/>
           </a:xfrm>
           <a:prstGeom prst="rect">
@@ -6722,7 +6722,7 @@
         </p:nvSpPr>
         <p:spPr>
           <a:xfrm>
-            <a:off x="10241280" y="4983480"/>
+            <a:off x="10241280" y="5925312"/>
             <a:ext cx="3931920" cy="274320"/>
           </a:xfrm>
           <a:prstGeom prst="rect">
@@ -6756,7 +6756,7 @@
         </p:nvSpPr>
         <p:spPr>
           <a:xfrm>
-            <a:off x="10241280" y="5285232"/>
+            <a:off x="10241280" y="6227064"/>
             <a:ext cx="3931920" cy="274320"/>
           </a:xfrm>
           <a:prstGeom prst="rect">
@@ -6777,7 +6777,7 @@
                   <a:srgbClr val="788296"/>
                 </a:solidFill>
               </a:rPr>
-              <a:t>20 infographics · 20 thumbnails</a:t>
+              <a:t>20 infographics (6 types)  ·  20 thumbnail variations</a:t>
             </a:r>
           </a:p>
         </p:txBody>
@@ -6790,7 +6790,7 @@
         </p:nvSpPr>
         <p:spPr>
           <a:xfrm>
-            <a:off x="10241280" y="5586984"/>
+            <a:off x="10241280" y="6528816"/>
             <a:ext cx="3931920" cy="274320"/>
           </a:xfrm>
           <a:prstGeom prst="rect">
@@ -6923,6 +6923,336 @@
                 </a:solidFill>
               </a:rPr>
               <a:t>CONFIDENTIAL</a:t>
+            </a:r>
+          </a:p>
+        </p:txBody>
+      </p:sp>
+      <p:sp>
+        <p:nvSpPr>
+          <p:cNvPr id="105" name="TextBox 104"/>
+          <p:cNvSpPr txBox="1"/>
+          <p:nvPr/>
+        </p:nvSpPr>
+        <p:spPr>
+          <a:xfrm>
+            <a:off x="10195560" y="4471416"/>
+            <a:ext cx="1005840" cy="228600"/>
+          </a:xfrm>
+          <a:prstGeom prst="rect">
+            <a:avLst/>
+          </a:prstGeom>
+          <a:noFill/>
+        </p:spPr>
+        <p:txBody>
+          <a:bodyPr wrap="none">
+            <a:spAutoFit/>
+          </a:bodyPr>
+          <a:lstStyle/>
+          <a:p>
+            <a:r>
+              <a:rPr sz="750" b="1">
+                <a:solidFill>
+                  <a:srgbClr val="788296"/>
+                </a:solidFill>
+              </a:rPr>
+              <a:t>Frontend:</a:t>
+            </a:r>
+          </a:p>
+        </p:txBody>
+      </p:sp>
+      <p:sp>
+        <p:nvSpPr>
+          <p:cNvPr id="106" name="TextBox 105"/>
+          <p:cNvSpPr txBox="1"/>
+          <p:nvPr/>
+        </p:nvSpPr>
+        <p:spPr>
+          <a:xfrm>
+            <a:off x="11247120" y="4471416"/>
+            <a:ext cx="2834640" cy="228600"/>
+          </a:xfrm>
+          <a:prstGeom prst="rect">
+            <a:avLst/>
+          </a:prstGeom>
+          <a:noFill/>
+        </p:spPr>
+        <p:txBody>
+          <a:bodyPr wrap="none">
+            <a:spAutoFit/>
+          </a:bodyPr>
+          <a:lstStyle/>
+          <a:p>
+            <a:r>
+              <a:rPr sz="750" b="0">
+                <a:solidFill>
+                  <a:srgbClr val="C8D7EB"/>
+                </a:solidFill>
+              </a:rPr>
+              <a:t>Next.js 16 · React · Tailwind CSS</a:t>
+            </a:r>
+          </a:p>
+        </p:txBody>
+      </p:sp>
+      <p:sp>
+        <p:nvSpPr>
+          <p:cNvPr id="107" name="TextBox 106"/>
+          <p:cNvSpPr txBox="1"/>
+          <p:nvPr/>
+        </p:nvSpPr>
+        <p:spPr>
+          <a:xfrm>
+            <a:off x="10195560" y="4736592"/>
+            <a:ext cx="1005840" cy="228600"/>
+          </a:xfrm>
+          <a:prstGeom prst="rect">
+            <a:avLst/>
+          </a:prstGeom>
+          <a:noFill/>
+        </p:spPr>
+        <p:txBody>
+          <a:bodyPr wrap="none">
+            <a:spAutoFit/>
+          </a:bodyPr>
+          <a:lstStyle/>
+          <a:p>
+            <a:r>
+              <a:rPr sz="750" b="1">
+                <a:solidFill>
+                  <a:srgbClr val="788296"/>
+                </a:solidFill>
+              </a:rPr>
+              <a:t>Observability:</a:t>
+            </a:r>
+          </a:p>
+        </p:txBody>
+      </p:sp>
+      <p:sp>
+        <p:nvSpPr>
+          <p:cNvPr id="108" name="TextBox 107"/>
+          <p:cNvSpPr txBox="1"/>
+          <p:nvPr/>
+        </p:nvSpPr>
+        <p:spPr>
+          <a:xfrm>
+            <a:off x="11247120" y="4736592"/>
+            <a:ext cx="2834640" cy="228600"/>
+          </a:xfrm>
+          <a:prstGeom prst="rect">
+            <a:avLst/>
+          </a:prstGeom>
+          <a:noFill/>
+        </p:spPr>
+        <p:txBody>
+          <a:bodyPr wrap="none">
+            <a:spAutoFit/>
+          </a:bodyPr>
+          <a:lstStyle/>
+          <a:p>
+            <a:r>
+              <a:rPr sz="750" b="0">
+                <a:solidFill>
+                  <a:srgbClr val="C8D7EB"/>
+                </a:solidFill>
+              </a:rPr>
+              <a:t>Winston logging · Request ID tracing</a:t>
+            </a:r>
+          </a:p>
+        </p:txBody>
+      </p:sp>
+      <p:sp>
+        <p:nvSpPr>
+          <p:cNvPr id="109" name="TextBox 108"/>
+          <p:cNvSpPr txBox="1"/>
+          <p:nvPr/>
+        </p:nvSpPr>
+        <p:spPr>
+          <a:xfrm>
+            <a:off x="5760720" y="5934456"/>
+            <a:ext cx="2926080" cy="182880"/>
+          </a:xfrm>
+          <a:prstGeom prst="rect">
+            <a:avLst/>
+          </a:prstGeom>
+          <a:noFill/>
+        </p:spPr>
+        <p:txBody>
+          <a:bodyPr wrap="none">
+            <a:spAutoFit/>
+          </a:bodyPr>
+          <a:lstStyle/>
+          <a:p>
+            <a:r>
+              <a:rPr sz="800" b="0">
+                <a:solidFill>
+                  <a:srgbClr val="788296"/>
+                </a:solidFill>
+              </a:rPr>
+              <a:t>• p95 Response Time</a:t>
+            </a:r>
+          </a:p>
+        </p:txBody>
+      </p:sp>
+      <p:sp>
+        <p:nvSpPr>
+          <p:cNvPr id="110" name="TextBox 109"/>
+          <p:cNvSpPr txBox="1"/>
+          <p:nvPr/>
+        </p:nvSpPr>
+        <p:spPr>
+          <a:xfrm>
+            <a:off x="8595360" y="5934456"/>
+            <a:ext cx="1005840" cy="182880"/>
+          </a:xfrm>
+          <a:prstGeom prst="rect">
+            <a:avLst/>
+          </a:prstGeom>
+          <a:noFill/>
+        </p:spPr>
+        <p:txBody>
+          <a:bodyPr wrap="none">
+            <a:spAutoFit/>
+          </a:bodyPr>
+          <a:lstStyle/>
+          <a:p>
+            <a:r>
+              <a:rPr sz="800" b="1">
+                <a:solidFill>
+                  <a:srgbClr val="06B6D4"/>
+                </a:solidFill>
+              </a:rPr>
+              <a:t>&lt; 2,000 ms</a:t>
+            </a:r>
+          </a:p>
+        </p:txBody>
+      </p:sp>
+      <p:sp>
+        <p:nvSpPr>
+          <p:cNvPr id="111" name="TextBox 110"/>
+          <p:cNvSpPr txBox="1"/>
+          <p:nvPr/>
+        </p:nvSpPr>
+        <p:spPr>
+          <a:xfrm>
+            <a:off x="5760720" y="6135624"/>
+            <a:ext cx="2926080" cy="182880"/>
+          </a:xfrm>
+          <a:prstGeom prst="rect">
+            <a:avLst/>
+          </a:prstGeom>
+          <a:noFill/>
+        </p:spPr>
+        <p:txBody>
+          <a:bodyPr wrap="none">
+            <a:spAutoFit/>
+          </a:bodyPr>
+          <a:lstStyle/>
+          <a:p>
+            <a:r>
+              <a:rPr sz="800" b="0">
+                <a:solidFill>
+                  <a:srgbClr val="788296"/>
+                </a:solidFill>
+              </a:rPr>
+              <a:t>• p99 Response Time</a:t>
+            </a:r>
+          </a:p>
+        </p:txBody>
+      </p:sp>
+      <p:sp>
+        <p:nvSpPr>
+          <p:cNvPr id="112" name="TextBox 111"/>
+          <p:cNvSpPr txBox="1"/>
+          <p:nvPr/>
+        </p:nvSpPr>
+        <p:spPr>
+          <a:xfrm>
+            <a:off x="8595360" y="6135624"/>
+            <a:ext cx="1005840" cy="182880"/>
+          </a:xfrm>
+          <a:prstGeom prst="rect">
+            <a:avLst/>
+          </a:prstGeom>
+          <a:noFill/>
+        </p:spPr>
+        <p:txBody>
+          <a:bodyPr wrap="none">
+            <a:spAutoFit/>
+          </a:bodyPr>
+          <a:lstStyle/>
+          <a:p>
+            <a:r>
+              <a:rPr sz="800" b="1">
+                <a:solidFill>
+                  <a:srgbClr val="6366F1"/>
+                </a:solidFill>
+              </a:rPr>
+              <a:t>&lt; 5,000 ms</a:t>
+            </a:r>
+          </a:p>
+        </p:txBody>
+      </p:sp>
+      <p:sp>
+        <p:nvSpPr>
+          <p:cNvPr id="113" name="TextBox 112"/>
+          <p:cNvSpPr txBox="1"/>
+          <p:nvPr/>
+        </p:nvSpPr>
+        <p:spPr>
+          <a:xfrm>
+            <a:off x="5760720" y="6336792"/>
+            <a:ext cx="2926080" cy="182880"/>
+          </a:xfrm>
+          <a:prstGeom prst="rect">
+            <a:avLst/>
+          </a:prstGeom>
+          <a:noFill/>
+        </p:spPr>
+        <p:txBody>
+          <a:bodyPr wrap="none">
+            <a:spAutoFit/>
+          </a:bodyPr>
+          <a:lstStyle/>
+          <a:p>
+            <a:r>
+              <a:rPr sz="800" b="0">
+                <a:solidFill>
+                  <a:srgbClr val="788296"/>
+                </a:solidFill>
+              </a:rPr>
+              <a:t>• Success Rate</a:t>
+            </a:r>
+          </a:p>
+        </p:txBody>
+      </p:sp>
+      <p:sp>
+        <p:nvSpPr>
+          <p:cNvPr id="114" name="TextBox 113"/>
+          <p:cNvSpPr txBox="1"/>
+          <p:nvPr/>
+        </p:nvSpPr>
+        <p:spPr>
+          <a:xfrm>
+            <a:off x="8595360" y="6336792"/>
+            <a:ext cx="1005840" cy="182880"/>
+          </a:xfrm>
+          <a:prstGeom prst="rect">
+            <a:avLst/>
+          </a:prstGeom>
+          <a:noFill/>
+        </p:spPr>
+        <p:txBody>
+          <a:bodyPr wrap="none">
+            <a:spAutoFit/>
+          </a:bodyPr>
+          <a:lstStyle/>
+          <a:p>
+            <a:r>
+              <a:rPr sz="800" b="1">
+                <a:solidFill>
+                  <a:srgbClr val="34D399"/>
+                </a:solidFill>
+              </a:rPr>
+              <a:t>≥ 99%</a:t>
             </a:r>
           </a:p>
         </p:txBody>

</xml_diff>